<commit_message>
Updated Sovereign data platform session with correct end slide
</commit_message>
<xml_diff>
--- a/(RS-EN) From Convenience to Control - Breaking Free from Big Tech Data Platforms/From Convenience to Control - Breaking Free from Big Tech Data Platforms.pptx
+++ b/(RS-EN) From Convenience to Control - Breaking Free from Big Tech Data Platforms/From Convenience to Control - Breaking Free from Big Tech Data Platforms.pptx
@@ -139,7 +139,7 @@
 <file path=ppt/revisionInfo.xml><?xml version="1.0" encoding="utf-8"?>
 <p1510:revInfo xmlns:a="http://schemas.openxmlformats.org/drawingml/2006/main" xmlns:r="http://schemas.openxmlformats.org/officeDocument/2006/relationships" xmlns:p1510="http://schemas.microsoft.com/office/powerpoint/2015/10/main">
   <p1510:revLst>
-    <p1510:client id="{C48AA9D1-6125-9943-9F3B-0EF6E23B2AF8}" v="26" dt="2026-08-20T12:21:39.234"/>
+    <p1510:client id="{C48AA9D1-6125-9943-9F3B-0EF6E23B2AF8}" v="27" dt="2026-08-20T18:11:54.217"/>
   </p1510:revLst>
 </p1510:revInfo>
 </file>
@@ -149,7 +149,7 @@
   <pc:docChgLst>
     <pc:chgData name="Enrico van de Laar" userId="a1491e60-2902-4014-98d0-d7a2530d65dc" providerId="ADAL" clId="{65D55A24-3580-5A51-8936-C715321EB719}"/>
     <pc:docChg chg="undo custSel addSld delSld modSld sldOrd">
-      <pc:chgData name="Enrico van de Laar" userId="a1491e60-2902-4014-98d0-d7a2530d65dc" providerId="ADAL" clId="{65D55A24-3580-5A51-8936-C715321EB719}" dt="2026-08-20T14:01:31.993" v="14624" actId="20577"/>
+      <pc:chgData name="Enrico van de Laar" userId="a1491e60-2902-4014-98d0-d7a2530d65dc" providerId="ADAL" clId="{65D55A24-3580-5A51-8936-C715321EB719}" dt="2026-08-20T18:12:00.866" v="14628" actId="1076"/>
       <pc:docMkLst>
         <pc:docMk/>
       </pc:docMkLst>
@@ -941,12 +941,36 @@
           </ac:picMkLst>
         </pc:picChg>
       </pc:sldChg>
-      <pc:sldChg chg="delSp mod modNotesTx">
-        <pc:chgData name="Enrico van de Laar" userId="a1491e60-2902-4014-98d0-d7a2530d65dc" providerId="ADAL" clId="{65D55A24-3580-5A51-8936-C715321EB719}" dt="2026-08-11T15:06:55.434" v="13752" actId="478"/>
+      <pc:sldChg chg="addSp delSp modSp mod modNotesTx">
+        <pc:chgData name="Enrico van de Laar" userId="a1491e60-2902-4014-98d0-d7a2530d65dc" providerId="ADAL" clId="{65D55A24-3580-5A51-8936-C715321EB719}" dt="2026-08-20T18:12:00.866" v="14628" actId="1076"/>
         <pc:sldMkLst>
           <pc:docMk/>
           <pc:sldMk cId="0" sldId="263"/>
         </pc:sldMkLst>
+        <pc:spChg chg="mod">
+          <ac:chgData name="Enrico van de Laar" userId="a1491e60-2902-4014-98d0-d7a2530d65dc" providerId="ADAL" clId="{65D55A24-3580-5A51-8936-C715321EB719}" dt="2026-08-20T18:11:52.481" v="14626" actId="6549"/>
+          <ac:spMkLst>
+            <pc:docMk/>
+            <pc:sldMk cId="0" sldId="263"/>
+            <ac:spMk id="8" creationId="{00000000-0000-0000-0000-000000000000}"/>
+          </ac:spMkLst>
+        </pc:spChg>
+        <pc:spChg chg="del">
+          <ac:chgData name="Enrico van de Laar" userId="a1491e60-2902-4014-98d0-d7a2530d65dc" providerId="ADAL" clId="{65D55A24-3580-5A51-8936-C715321EB719}" dt="2026-08-20T18:06:27.911" v="14625" actId="478"/>
+          <ac:spMkLst>
+            <pc:docMk/>
+            <pc:sldMk cId="0" sldId="263"/>
+            <ac:spMk id="9" creationId="{00000000-0000-0000-0000-000000000000}"/>
+          </ac:spMkLst>
+        </pc:spChg>
+        <pc:picChg chg="add mod">
+          <ac:chgData name="Enrico van de Laar" userId="a1491e60-2902-4014-98d0-d7a2530d65dc" providerId="ADAL" clId="{65D55A24-3580-5A51-8936-C715321EB719}" dt="2026-08-20T18:12:00.866" v="14628" actId="1076"/>
+          <ac:picMkLst>
+            <pc:docMk/>
+            <pc:sldMk cId="0" sldId="263"/>
+            <ac:picMk id="4" creationId="{8CF28269-E1E8-71FB-CE07-80604A624716}"/>
+          </ac:picMkLst>
+        </pc:picChg>
       </pc:sldChg>
       <pc:sldChg chg="addSp delSp modSp mod ord modNotesTx">
         <pc:chgData name="Enrico van de Laar" userId="a1491e60-2902-4014-98d0-d7a2530d65dc" providerId="ADAL" clId="{65D55A24-3580-5A51-8936-C715321EB719}" dt="2026-08-11T13:11:22.379" v="8486" actId="20577"/>
@@ -6078,13 +6102,8 @@
             </a:pPr>
             <a:r>
               <a:rPr lang="en-US" b="0" noProof="0" dirty="0"/>
-              <a:t>However, we still use O365 for our </a:t>
-            </a:r>
-            <a:r>
-              <a:rPr lang="en-US" b="0" noProof="0"/>
-              <a:t>internal environment</a:t>
-            </a:r>
-            <a:endParaRPr lang="en-US" b="0" noProof="0" dirty="0"/>
+              <a:t>However, we still use O365 for our internal environment</a:t>
+            </a:r>
           </a:p>
         </p:txBody>
       </p:sp>
@@ -20649,60 +20668,40 @@
             <a:pPr marL="0" indent="0" algn="ctr">
               <a:buNone/>
             </a:pPr>
-            <a:r>
-              <a:rPr lang="en-US" sz="3000" b="1" dirty="0">
-                <a:solidFill>
-                  <a:srgbClr val="0A0A0A"/>
-                </a:solidFill>
-                <a:latin typeface="JetBrains Mono ExtraBold" pitchFamily="34" charset="0"/>
-                <a:ea typeface="JetBrains Mono ExtraBold" pitchFamily="34" charset="-122"/>
-                <a:cs typeface="JetBrains Mono ExtraBold" pitchFamily="34" charset="-120"/>
-              </a:rPr>
-              <a:t>[ QR ]</a:t>
-            </a:r>
             <a:endParaRPr lang="en-US" sz="3000" dirty="0"/>
           </a:p>
         </p:txBody>
       </p:sp>
-      <p:sp>
-        <p:nvSpPr>
-          <p:cNvPr id="9" name="Text 7"/>
-          <p:cNvSpPr/>
+      <p:pic>
+        <p:nvPicPr>
+          <p:cNvPr id="4" name="Picture 3" descr="QR Code Image">
+            <a:extLst>
+              <a:ext uri="{FF2B5EF4-FFF2-40B4-BE49-F238E27FC236}">
+                <a16:creationId xmlns:a16="http://schemas.microsoft.com/office/drawing/2014/main" id="{8CF28269-E1E8-71FB-CE07-80604A624716}"/>
+              </a:ext>
+            </a:extLst>
+          </p:cNvPr>
+          <p:cNvPicPr>
+            <a:picLocks noChangeAspect="1"/>
+          </p:cNvPicPr>
           <p:nvPr/>
-        </p:nvSpPr>
+        </p:nvPicPr>
+        <p:blipFill>
+          <a:blip r:embed="rId3"/>
+          <a:stretch>
+            <a:fillRect/>
+          </a:stretch>
+        </p:blipFill>
         <p:spPr>
           <a:xfrm>
-            <a:off x="8686800" y="4297680"/>
-            <a:ext cx="2834640" cy="320040"/>
+            <a:off x="8376920" y="1352613"/>
+            <a:ext cx="3175000" cy="3175000"/>
           </a:xfrm>
           <a:prstGeom prst="rect">
             <a:avLst/>
           </a:prstGeom>
-          <a:noFill/>
-          <a:ln/>
         </p:spPr>
-        <p:txBody>
-          <a:bodyPr wrap="square" lIns="0" tIns="0" rIns="0" bIns="0" rtlCol="0" anchor="ctr"/>
-          <a:lstStyle/>
-          <a:p>
-            <a:pPr marL="0" indent="0" algn="ctr">
-              <a:buNone/>
-            </a:pPr>
-            <a:r>
-              <a:rPr lang="en-US" sz="1100" dirty="0">
-                <a:solidFill>
-                  <a:srgbClr val="A1A1AA"/>
-                </a:solidFill>
-                <a:latin typeface="JetBrains Mono Medium" pitchFamily="34" charset="0"/>
-                <a:ea typeface="JetBrains Mono Medium" pitchFamily="34" charset="-122"/>
-                <a:cs typeface="JetBrains Mono Medium" pitchFamily="34" charset="-120"/>
-              </a:rPr>
-              <a:t>replace with your signup QR</a:t>
-            </a:r>
-            <a:endParaRPr lang="en-US" sz="1100" dirty="0"/>
-          </a:p>
-        </p:txBody>
-      </p:sp>
+      </p:pic>
     </p:spTree>
   </p:cSld>
   <p:clrMapOvr>

</xml_diff>